<commit_message>
Describe the level queue's intended capacity rule on its slide
The level queue slide now says consumed history is dropped behind the head
and the entry grows per slot ahead of it, the behavior issue #66 asks for.
The notes explain tombstones and the cap, and name the current contract's
gap. The PowerPoint copy carries the same change.

Co-Authored-By: Claude Fable 5.1 <noreply@anthropic.com>
</commit_message>
<xml_diff>
--- a/docs/talk/pagebook-talk.pptx
+++ b/docs/talk/pagebook-talk.pptx
@@ -386,11 +386,19 @@
           <a:lstStyle/>
           <a:p>
             <a:r>
-              <a:rPr lang="en-US" dirty="0"/>
-              <a:t>The whole FIFO at one price lives in one entry: a generation counter, a head sequence number, the open total, and a vector of quantity slots. Sequence numbers are slot positions. A rest pushes onto the end. A take decrements the head slot in place and advances the head. A cancel zeroes its slot. Nothing is ever moved or compacted.
-The entry is sized to occupancy: 124 bytes empty, 12 more per resting order, about 900 bytes at the default cap of 64 orders. A swept level is written empty, so the hot-path writes are small.
-A taker that consumes the whole level prices it from the open total, writes the entry empty, and bumps the generation. It never reads the slots. Sweeping a level with sixty makers costs one write, the same as sweeping one. And because the queue lives under the key the transaction already declared, a queue that deepens in flight changes nothing about the footprint. Level entries are never deleted; the generation counter must survive so old makers can still settle.</a:t>
-            </a:r>
+              <a:rPr lang="en-US"/>
+              <a:t>The whole FIFO at one price lives in one entry: a generation counter, a head sequence number, the open total, and a vector of quantity slots. Sequence numbers are slot positions. A rest pushes onto the end. A take decrements the head slot in place and advances the head. A cancel zeroes its slot. Nothing is ever moved or compacted.The entry is sized to occupancy: 124 bytes empty, 12 more per resting order, about 900 bytes at the default cap of 64 orders. A swept level is written empty, so the hot-path writes are small.A taker that consumes the whole level prices it from the open total, writes the entry empty, and bumps the generation. It never reads the slots. Sweeping a level with sixty makers costs one write, the same as sweeping one. And because the queue lives under the key the transaction already declared, a queue that deepens in flight changes nothing about the footprint. Level entries are never deleted; the generation counter must survive so old makers can still settle.</a:t>
+            </a:r>
+          </a:p>
+          <a:p>
+            <a:endParaRPr lang="en-US"/>
+          </a:p>
+          <a:p>
+            <a:r>
+              <a:rPr lang="en-US"/>
+              <a:t>A cancel leaves its slot in place at zero, a tombstone, because later makers' sequence numbers point at positions and their records cannot be rewritten. The walk skips tombstones. The level cap of 64 counts the slots ahead of the head, live or tombstoned; a sweep or a rest into an empty level starts a new generation and clears them. The current contract also keeps filled history behind the head until then, which is issue 66: co-located makers refreshing one tick can fill it with tombstones. The fix drops the consumed prefix behind the head, which the slide describes.</a:t>
+            </a:r>
+            <a:endParaRPr lang="en-US" dirty="0"/>
           </a:p>
         </p:txBody>
       </p:sp>
@@ -2280,23 +2288,29 @@
               <a:buChar char="•"/>
             </a:pPr>
             <a:r>
-              <a:rPr lang="en-US" sz="2000" b="1" dirty="0">
+              <a:rPr lang="en-US" sz="2000" b="1">
                 <a:solidFill>
                   <a:srgbClr val="E7E3D8"/>
                 </a:solidFill>
                 <a:latin typeface="Calibri" panose="020F0502020204030204" pitchFamily="34" charset="0"/>
               </a:rPr>
-              <a:t>One entry per price level so crossing a price touches one key however many orders rest there.</a:t>
-            </a:r>
-            <a:r>
-              <a:rPr lang="en-US" sz="2000" dirty="0">
+              <a:t>One entry per price level, so crossing a price touches one key however many orders rest there.</a:t>
+            </a:r>
+            <a:r>
+              <a:rPr lang="en-US" sz="2000">
                 <a:solidFill>
                   <a:srgbClr val="E7E3D8"/>
                 </a:solidFill>
                 <a:latin typeface="Calibri" panose="020F0502020204030204" pitchFamily="34" charset="0"/>
               </a:rPr>
-              <a:t> A FIFO of order quantities: appends go at the tail, the head advances, nothing is ever moved. 124 B empty, 12 B per resting order</a:t>
-            </a:r>
+              <a:t> A FIFO of order quantities: appends go at the tail, the head advances, consumed history is dropped behind it. 124 B empty, 12 B per slot ahead of the head</a:t>
+            </a:r>
+            <a:endParaRPr lang="en-US" sz="2000" dirty="0">
+              <a:solidFill>
+                <a:srgbClr val="E7E3D8"/>
+              </a:solidFill>
+              <a:latin typeface="Calibri" panose="020F0502020204030204" pitchFamily="34" charset="0"/>
+            </a:endParaRPr>
           </a:p>
           <a:p>
             <a:pPr marL="457200" indent="-457200">
@@ -6161,16 +6175,52 @@
               <a:t>Try it: </a:t>
             </a:r>
             <a:r>
-              <a:rPr lang="en-US" sz="1900">
+              <a:rPr lang="en-US" sz="1900" dirty="0" err="1">
                 <a:solidFill>
                   <a:srgbClr val="7EA9E0"/>
                 </a:solidFill>
                 <a:latin typeface="Calibri" panose="020F0502020204030204" pitchFamily="34" charset="0"/>
               </a:rPr>
-              <a:t>tomerweller.com/pagebook/explainer/tick-grids.html</a:t>
-            </a:r>
-            <a:r>
-              <a:rPr lang="en-US" sz="1900">
+              <a:t>tomerweller.com</a:t>
+            </a:r>
+            <a:r>
+              <a:rPr lang="en-US" sz="1900" dirty="0">
+                <a:solidFill>
+                  <a:srgbClr val="7EA9E0"/>
+                </a:solidFill>
+                <a:latin typeface="Calibri" panose="020F0502020204030204" pitchFamily="34" charset="0"/>
+              </a:rPr>
+              <a:t>/</a:t>
+            </a:r>
+            <a:r>
+              <a:rPr lang="en-US" sz="1900" dirty="0" err="1">
+                <a:solidFill>
+                  <a:srgbClr val="7EA9E0"/>
+                </a:solidFill>
+                <a:latin typeface="Calibri" panose="020F0502020204030204" pitchFamily="34" charset="0"/>
+              </a:rPr>
+              <a:t>pagebook</a:t>
+            </a:r>
+            <a:r>
+              <a:rPr lang="en-US" sz="1900" dirty="0">
+                <a:solidFill>
+                  <a:srgbClr val="7EA9E0"/>
+                </a:solidFill>
+                <a:latin typeface="Calibri" panose="020F0502020204030204" pitchFamily="34" charset="0"/>
+              </a:rPr>
+              <a:t>/explainer/tick-</a:t>
+            </a:r>
+            <a:r>
+              <a:rPr lang="en-US" sz="1900" dirty="0" err="1">
+                <a:solidFill>
+                  <a:srgbClr val="7EA9E0"/>
+                </a:solidFill>
+                <a:latin typeface="Calibri" panose="020F0502020204030204" pitchFamily="34" charset="0"/>
+              </a:rPr>
+              <a:t>grids.html</a:t>
+            </a:r>
+            <a:r>
+              <a:rPr lang="en-US" sz="1900" dirty="0">
                 <a:solidFill>
                   <a:srgbClr val="E7E3D8"/>
                 </a:solidFill>
@@ -6178,12 +6228,6 @@
               </a:rPr>
               <a:t>, drag the price and watch each grid respond</a:t>
             </a:r>
-            <a:endParaRPr lang="en-US" sz="1900" dirty="0">
-              <a:solidFill>
-                <a:srgbClr val="E7E3D8"/>
-              </a:solidFill>
-              <a:latin typeface="Calibri" panose="020F0502020204030204" pitchFamily="34" charset="0"/>
-            </a:endParaRPr>
           </a:p>
         </p:txBody>
       </p:sp>

</xml_diff>

<commit_message>
Redraw the level queue figure with the consumed prefix dropped
The deck's level queue diagram now matches its slide: sequence numbers
behind the head are drawn as dropped ghosts, a tombstone ahead of the head
stays, the head is the vector's first slot, and the size note counts slots
ahead of the head. The explainer's copy is unchanged, since it documents the
contract as it stands (#66).

Co-Authored-By: Claude Fable 5.1 <noreply@anthropic.com>
</commit_message>
<xml_diff>
--- a/docs/talk/pagebook-talk.pptx
+++ b/docs/talk/pagebook-talk.pptx
@@ -2228,11 +2228,106 @@
           </a:p>
         </p:txBody>
       </p:sp>
+      <p:sp>
+        <p:nvSpPr>
+          <p:cNvPr id="7" name="TextBox 6">
+            <a:extLst>
+              <a:ext uri="{FF2B5EF4-FFF2-40B4-BE49-F238E27FC236}">
+                <a16:creationId xmlns:a16="http://schemas.microsoft.com/office/drawing/2014/main" id="{C68FBD9E-B521-59F2-58CC-E64D75723F3E}"/>
+              </a:ext>
+            </a:extLst>
+          </p:cNvPr>
+          <p:cNvSpPr txBox="1"/>
+          <p:nvPr/>
+        </p:nvSpPr>
+        <p:spPr>
+          <a:xfrm>
+            <a:off x="635000" y="1498600"/>
+            <a:ext cx="10922000" cy="1708160"/>
+          </a:xfrm>
+          <a:prstGeom prst="rect">
+            <a:avLst/>
+          </a:prstGeom>
+          <a:noFill/>
+        </p:spPr>
+        <p:txBody>
+          <a:bodyPr vert="horz" rtlCol="0">
+            <a:spAutoFit/>
+          </a:bodyPr>
+          <a:lstStyle/>
+          <a:p>
+            <a:pPr marL="457200" indent="-457200">
+              <a:spcAft>
+                <a:spcPts val="600"/>
+              </a:spcAft>
+              <a:buFont typeface="+mj-lt"/>
+              <a:buChar char="•"/>
+            </a:pPr>
+            <a:r>
+              <a:rPr lang="en-US" sz="2000" b="1">
+                <a:solidFill>
+                  <a:srgbClr val="E7E3D8"/>
+                </a:solidFill>
+                <a:latin typeface="Calibri" panose="020F0502020204030204" pitchFamily="34" charset="0"/>
+              </a:rPr>
+              <a:t>One entry per price level, so crossing a price touches one key however many orders rest there.</a:t>
+            </a:r>
+            <a:r>
+              <a:rPr lang="en-US" sz="2000">
+                <a:solidFill>
+                  <a:srgbClr val="E7E3D8"/>
+                </a:solidFill>
+                <a:latin typeface="Calibri" panose="020F0502020204030204" pitchFamily="34" charset="0"/>
+              </a:rPr>
+              <a:t> A FIFO of order quantities: appends go at the tail, the head advances, consumed history is dropped behind it. 124 B empty, 12 B per slot ahead of the head</a:t>
+            </a:r>
+            <a:endParaRPr lang="en-US" sz="2000" dirty="0">
+              <a:solidFill>
+                <a:srgbClr val="E7E3D8"/>
+              </a:solidFill>
+              <a:latin typeface="Calibri" panose="020F0502020204030204" pitchFamily="34" charset="0"/>
+            </a:endParaRPr>
+          </a:p>
+          <a:p>
+            <a:pPr marL="457200" indent="-457200">
+              <a:spcAft>
+                <a:spcPts val="600"/>
+              </a:spcAft>
+              <a:buFont typeface="+mj-lt"/>
+              <a:buChar char="•"/>
+            </a:pPr>
+            <a:r>
+              <a:rPr lang="en-US" sz="2000" b="1" dirty="0">
+                <a:solidFill>
+                  <a:srgbClr val="E7E3D8"/>
+                </a:solidFill>
+                <a:latin typeface="Calibri" panose="020F0502020204030204" pitchFamily="34" charset="0"/>
+              </a:rPr>
+              <a:t>A sweep is one write.</a:t>
+            </a:r>
+            <a:r>
+              <a:rPr lang="en-US" sz="2000" dirty="0">
+                <a:solidFill>
+                  <a:srgbClr val="E7E3D8"/>
+                </a:solidFill>
+                <a:latin typeface="Calibri" panose="020F0502020204030204" pitchFamily="34" charset="0"/>
+              </a:rPr>
+              <a:t> A taker that clears the level prices it from the open total and writes it empty without reading a single slot. Matching cost scales with levels crossed, not with makers</a:t>
+            </a:r>
+          </a:p>
+        </p:txBody>
+      </p:sp>
       <p:pic>
         <p:nvPicPr>
-          <p:cNvPr id="4" name="Image 0" descr="fig/fig09.png"/>
+          <p:cNvPr id="6" name="Picture 5">
+            <a:extLst>
+              <a:ext uri="{FF2B5EF4-FFF2-40B4-BE49-F238E27FC236}">
+                <a16:creationId xmlns:a16="http://schemas.microsoft.com/office/drawing/2014/main" id="{57E27BF9-768C-E8F8-3A4F-0182A95224CE}"/>
+              </a:ext>
+            </a:extLst>
+          </p:cNvPr>
           <p:cNvPicPr>
-            <a:picLocks noChangeAspect="1"/>
+            <a:picLocks/>
           </p:cNvPicPr>
           <p:nvPr/>
         </p:nvPicPr>
@@ -2252,95 +2347,6 @@
           </a:prstGeom>
         </p:spPr>
       </p:pic>
-      <p:sp>
-        <p:nvSpPr>
-          <p:cNvPr id="7" name="TextBox 6">
-            <a:extLst>
-              <a:ext uri="{FF2B5EF4-FFF2-40B4-BE49-F238E27FC236}">
-                <a16:creationId xmlns:a16="http://schemas.microsoft.com/office/drawing/2014/main" id="{C68FBD9E-B521-59F2-58CC-E64D75723F3E}"/>
-              </a:ext>
-            </a:extLst>
-          </p:cNvPr>
-          <p:cNvSpPr txBox="1"/>
-          <p:nvPr/>
-        </p:nvSpPr>
-        <p:spPr>
-          <a:xfrm>
-            <a:off x="635000" y="1498600"/>
-            <a:ext cx="10922000" cy="1708160"/>
-          </a:xfrm>
-          <a:prstGeom prst="rect">
-            <a:avLst/>
-          </a:prstGeom>
-          <a:noFill/>
-        </p:spPr>
-        <p:txBody>
-          <a:bodyPr vert="horz" rtlCol="0">
-            <a:spAutoFit/>
-          </a:bodyPr>
-          <a:lstStyle/>
-          <a:p>
-            <a:pPr marL="457200" indent="-457200">
-              <a:spcAft>
-                <a:spcPts val="600"/>
-              </a:spcAft>
-              <a:buFont typeface="+mj-lt"/>
-              <a:buChar char="•"/>
-            </a:pPr>
-            <a:r>
-              <a:rPr lang="en-US" sz="2000" b="1">
-                <a:solidFill>
-                  <a:srgbClr val="E7E3D8"/>
-                </a:solidFill>
-                <a:latin typeface="Calibri" panose="020F0502020204030204" pitchFamily="34" charset="0"/>
-              </a:rPr>
-              <a:t>One entry per price level, so crossing a price touches one key however many orders rest there.</a:t>
-            </a:r>
-            <a:r>
-              <a:rPr lang="en-US" sz="2000">
-                <a:solidFill>
-                  <a:srgbClr val="E7E3D8"/>
-                </a:solidFill>
-                <a:latin typeface="Calibri" panose="020F0502020204030204" pitchFamily="34" charset="0"/>
-              </a:rPr>
-              <a:t> A FIFO of order quantities: appends go at the tail, the head advances, consumed history is dropped behind it. 124 B empty, 12 B per slot ahead of the head</a:t>
-            </a:r>
-            <a:endParaRPr lang="en-US" sz="2000" dirty="0">
-              <a:solidFill>
-                <a:srgbClr val="E7E3D8"/>
-              </a:solidFill>
-              <a:latin typeface="Calibri" panose="020F0502020204030204" pitchFamily="34" charset="0"/>
-            </a:endParaRPr>
-          </a:p>
-          <a:p>
-            <a:pPr marL="457200" indent="-457200">
-              <a:spcAft>
-                <a:spcPts val="600"/>
-              </a:spcAft>
-              <a:buFont typeface="+mj-lt"/>
-              <a:buChar char="•"/>
-            </a:pPr>
-            <a:r>
-              <a:rPr lang="en-US" sz="2000" b="1" dirty="0">
-                <a:solidFill>
-                  <a:srgbClr val="E7E3D8"/>
-                </a:solidFill>
-                <a:latin typeface="Calibri" panose="020F0502020204030204" pitchFamily="34" charset="0"/>
-              </a:rPr>
-              <a:t>A sweep is one write.</a:t>
-            </a:r>
-            <a:r>
-              <a:rPr lang="en-US" sz="2000" dirty="0">
-                <a:solidFill>
-                  <a:srgbClr val="E7E3D8"/>
-                </a:solidFill>
-                <a:latin typeface="Calibri" panose="020F0502020204030204" pitchFamily="34" charset="0"/>
-              </a:rPr>
-              <a:t> A taker that clears the level prices it from the open total and writes it empty without reading a single slot. Matching cost scales with levels crossed, not with makers</a:t>
-            </a:r>
-          </a:p>
-        </p:txBody>
-      </p:sp>
     </p:spTree>
   </p:cSld>
   <p:clrMapOvr>

</xml_diff>

<commit_message>
Simplify the level queue figure: no tombstone
The deck's level queue diagram now shows only the dropped prefix, the open
slots from the head, and the empty tail; tombstones stay in the notes.

Co-Authored-By: Claude Fable 5.1 <noreply@anthropic.com>
</commit_message>
<xml_diff>
--- a/docs/talk/pagebook-talk.pptx
+++ b/docs/talk/pagebook-talk.pptx
@@ -2228,95 +2228,6 @@
           </a:p>
         </p:txBody>
       </p:sp>
-      <p:sp>
-        <p:nvSpPr>
-          <p:cNvPr id="7" name="TextBox 6">
-            <a:extLst>
-              <a:ext uri="{FF2B5EF4-FFF2-40B4-BE49-F238E27FC236}">
-                <a16:creationId xmlns:a16="http://schemas.microsoft.com/office/drawing/2014/main" id="{C68FBD9E-B521-59F2-58CC-E64D75723F3E}"/>
-              </a:ext>
-            </a:extLst>
-          </p:cNvPr>
-          <p:cNvSpPr txBox="1"/>
-          <p:nvPr/>
-        </p:nvSpPr>
-        <p:spPr>
-          <a:xfrm>
-            <a:off x="635000" y="1498600"/>
-            <a:ext cx="10922000" cy="1708160"/>
-          </a:xfrm>
-          <a:prstGeom prst="rect">
-            <a:avLst/>
-          </a:prstGeom>
-          <a:noFill/>
-        </p:spPr>
-        <p:txBody>
-          <a:bodyPr vert="horz" rtlCol="0">
-            <a:spAutoFit/>
-          </a:bodyPr>
-          <a:lstStyle/>
-          <a:p>
-            <a:pPr marL="457200" indent="-457200">
-              <a:spcAft>
-                <a:spcPts val="600"/>
-              </a:spcAft>
-              <a:buFont typeface="+mj-lt"/>
-              <a:buChar char="•"/>
-            </a:pPr>
-            <a:r>
-              <a:rPr lang="en-US" sz="2000" b="1">
-                <a:solidFill>
-                  <a:srgbClr val="E7E3D8"/>
-                </a:solidFill>
-                <a:latin typeface="Calibri" panose="020F0502020204030204" pitchFamily="34" charset="0"/>
-              </a:rPr>
-              <a:t>One entry per price level, so crossing a price touches one key however many orders rest there.</a:t>
-            </a:r>
-            <a:r>
-              <a:rPr lang="en-US" sz="2000">
-                <a:solidFill>
-                  <a:srgbClr val="E7E3D8"/>
-                </a:solidFill>
-                <a:latin typeface="Calibri" panose="020F0502020204030204" pitchFamily="34" charset="0"/>
-              </a:rPr>
-              <a:t> A FIFO of order quantities: appends go at the tail, the head advances, consumed history is dropped behind it. 124 B empty, 12 B per slot ahead of the head</a:t>
-            </a:r>
-            <a:endParaRPr lang="en-US" sz="2000" dirty="0">
-              <a:solidFill>
-                <a:srgbClr val="E7E3D8"/>
-              </a:solidFill>
-              <a:latin typeface="Calibri" panose="020F0502020204030204" pitchFamily="34" charset="0"/>
-            </a:endParaRPr>
-          </a:p>
-          <a:p>
-            <a:pPr marL="457200" indent="-457200">
-              <a:spcAft>
-                <a:spcPts val="600"/>
-              </a:spcAft>
-              <a:buFont typeface="+mj-lt"/>
-              <a:buChar char="•"/>
-            </a:pPr>
-            <a:r>
-              <a:rPr lang="en-US" sz="2000" b="1" dirty="0">
-                <a:solidFill>
-                  <a:srgbClr val="E7E3D8"/>
-                </a:solidFill>
-                <a:latin typeface="Calibri" panose="020F0502020204030204" pitchFamily="34" charset="0"/>
-              </a:rPr>
-              <a:t>A sweep is one write.</a:t>
-            </a:r>
-            <a:r>
-              <a:rPr lang="en-US" sz="2000" dirty="0">
-                <a:solidFill>
-                  <a:srgbClr val="E7E3D8"/>
-                </a:solidFill>
-                <a:latin typeface="Calibri" panose="020F0502020204030204" pitchFamily="34" charset="0"/>
-              </a:rPr>
-              <a:t> A taker that clears the level prices it from the open total and writes it empty without reading a single slot. Matching cost scales with levels crossed, not with makers</a:t>
-            </a:r>
-          </a:p>
-        </p:txBody>
-      </p:sp>
       <p:pic>
         <p:nvPicPr>
           <p:cNvPr id="6" name="Picture 5">
@@ -2341,6 +2252,36 @@
           <a:xfrm>
             <a:off x="1313385" y="3403600"/>
             <a:ext cx="9565230" cy="3276600"/>
+          </a:xfrm>
+          <a:prstGeom prst="rect">
+            <a:avLst/>
+          </a:prstGeom>
+        </p:spPr>
+      </p:pic>
+      <p:pic>
+        <p:nvPicPr>
+          <p:cNvPr id="9" name="Picture 8">
+            <a:extLst>
+              <a:ext uri="{FF2B5EF4-FFF2-40B4-BE49-F238E27FC236}">
+                <a16:creationId xmlns:a16="http://schemas.microsoft.com/office/drawing/2014/main" id="{1775FC57-FC7C-D9F4-2DC5-48AB3A369914}"/>
+              </a:ext>
+            </a:extLst>
+          </p:cNvPr>
+          <p:cNvPicPr>
+            <a:picLocks/>
+          </p:cNvPicPr>
+          <p:nvPr/>
+        </p:nvPicPr>
+        <p:blipFill>
+          <a:blip r:embed="rId4"/>
+          <a:stretch>
+            <a:fillRect/>
+          </a:stretch>
+        </p:blipFill>
+        <p:spPr>
+          <a:xfrm>
+            <a:off x="635000" y="1498600"/>
+            <a:ext cx="10922000" cy="1708160"/>
           </a:xfrm>
           <a:prstGeom prst="rect">
             <a:avLst/>

</xml_diff>

<commit_message>
Drop the "one way to fail" bullet from the taker walk slide
The notes keep the footprint trap and the exactness point.

Co-Authored-By: Claude Fable 5.1 <noreply@anthropic.com>
</commit_message>
<xml_diff>
--- a/docs/talk/pagebook-talk.pptx
+++ b/docs/talk/pagebook-talk.pptx
@@ -2707,7 +2707,7 @@
         <p:spPr>
           <a:xfrm>
             <a:off x="635000" y="1498600"/>
-            <a:ext cx="10922000" cy="1708160"/>
+            <a:ext cx="10922000" cy="1015663"/>
           </a:xfrm>
           <a:prstGeom prst="rect">
             <a:avLst/>
@@ -2751,33 +2751,6 @@
               </a:solidFill>
               <a:latin typeface="Calibri" panose="020F0502020204030204" pitchFamily="34" charset="0"/>
             </a:endParaRPr>
-          </a:p>
-          <a:p>
-            <a:pPr marL="457200" indent="-457200">
-              <a:spcAft>
-                <a:spcPts val="600"/>
-              </a:spcAft>
-              <a:buFont typeface="+mj-lt"/>
-              <a:buChar char="•"/>
-            </a:pPr>
-            <a:r>
-              <a:rPr lang="en-US" sz="2000" b="1" dirty="0">
-                <a:solidFill>
-                  <a:srgbClr val="E7E3D8"/>
-                </a:solidFill>
-                <a:latin typeface="Calibri" panose="020F0502020204030204" pitchFamily="34" charset="0"/>
-              </a:rPr>
-              <a:t>One way to fail.</a:t>
-            </a:r>
-            <a:r>
-              <a:rPr lang="en-US" sz="2000" dirty="0">
-                <a:solidFill>
-                  <a:srgbClr val="E7E3D8"/>
-                </a:solidFill>
-                <a:latin typeface="Calibri" panose="020F0502020204030204" pitchFamily="34" charset="0"/>
-              </a:rPr>
-              <a:t> Only a walk past the padded band fails on the footprint; every other outcome is a typed result. Arithmetic is exact, and the taker fee is the only rounding</a:t>
-            </a:r>
           </a:p>
         </p:txBody>
       </p:sp>

</xml_diff>